<commit_message>
Updated image schematic to include Azure container instance
</commit_message>
<xml_diff>
--- a/images/schematic.pptx
+++ b/images/schematic.pptx
@@ -104,6 +104,11 @@
       </a:defRPr>
     </a:lvl9pPr>
   </p:defaultTextStyle>
+  <p:extLst>
+    <p:ext uri="{EFAFB233-063F-42B5-8137-9DF3F51BA10A}">
+      <p15:sldGuideLst xmlns:p15="http://schemas.microsoft.com/office/powerpoint/2012/main"/>
+    </p:ext>
+  </p:extLst>
 </p:presentation>
 </file>
 
@@ -256,7 +261,7 @@
           <a:p>
             <a:fld id="{06C350D9-E559-450B-A5B6-D4D031A8BEDA}" type="datetimeFigureOut">
               <a:rPr lang="en-SG" smtClean="0"/>
-              <a:t>22/9/2024</a:t>
+              <a:t>9/2/2025</a:t>
             </a:fld>
             <a:endParaRPr lang="en-SG"/>
           </a:p>
@@ -456,7 +461,7 @@
           <a:p>
             <a:fld id="{06C350D9-E559-450B-A5B6-D4D031A8BEDA}" type="datetimeFigureOut">
               <a:rPr lang="en-SG" smtClean="0"/>
-              <a:t>22/9/2024</a:t>
+              <a:t>9/2/2025</a:t>
             </a:fld>
             <a:endParaRPr lang="en-SG"/>
           </a:p>
@@ -666,7 +671,7 @@
           <a:p>
             <a:fld id="{06C350D9-E559-450B-A5B6-D4D031A8BEDA}" type="datetimeFigureOut">
               <a:rPr lang="en-SG" smtClean="0"/>
-              <a:t>22/9/2024</a:t>
+              <a:t>9/2/2025</a:t>
             </a:fld>
             <a:endParaRPr lang="en-SG"/>
           </a:p>
@@ -866,7 +871,7 @@
           <a:p>
             <a:fld id="{06C350D9-E559-450B-A5B6-D4D031A8BEDA}" type="datetimeFigureOut">
               <a:rPr lang="en-SG" smtClean="0"/>
-              <a:t>22/9/2024</a:t>
+              <a:t>9/2/2025</a:t>
             </a:fld>
             <a:endParaRPr lang="en-SG"/>
           </a:p>
@@ -1142,7 +1147,7 @@
           <a:p>
             <a:fld id="{06C350D9-E559-450B-A5B6-D4D031A8BEDA}" type="datetimeFigureOut">
               <a:rPr lang="en-SG" smtClean="0"/>
-              <a:t>22/9/2024</a:t>
+              <a:t>9/2/2025</a:t>
             </a:fld>
             <a:endParaRPr lang="en-SG"/>
           </a:p>
@@ -1410,7 +1415,7 @@
           <a:p>
             <a:fld id="{06C350D9-E559-450B-A5B6-D4D031A8BEDA}" type="datetimeFigureOut">
               <a:rPr lang="en-SG" smtClean="0"/>
-              <a:t>22/9/2024</a:t>
+              <a:t>9/2/2025</a:t>
             </a:fld>
             <a:endParaRPr lang="en-SG"/>
           </a:p>
@@ -1825,7 +1830,7 @@
           <a:p>
             <a:fld id="{06C350D9-E559-450B-A5B6-D4D031A8BEDA}" type="datetimeFigureOut">
               <a:rPr lang="en-SG" smtClean="0"/>
-              <a:t>22/9/2024</a:t>
+              <a:t>9/2/2025</a:t>
             </a:fld>
             <a:endParaRPr lang="en-SG"/>
           </a:p>
@@ -1967,7 +1972,7 @@
           <a:p>
             <a:fld id="{06C350D9-E559-450B-A5B6-D4D031A8BEDA}" type="datetimeFigureOut">
               <a:rPr lang="en-SG" smtClean="0"/>
-              <a:t>22/9/2024</a:t>
+              <a:t>9/2/2025</a:t>
             </a:fld>
             <a:endParaRPr lang="en-SG"/>
           </a:p>
@@ -2080,7 +2085,7 @@
           <a:p>
             <a:fld id="{06C350D9-E559-450B-A5B6-D4D031A8BEDA}" type="datetimeFigureOut">
               <a:rPr lang="en-SG" smtClean="0"/>
-              <a:t>22/9/2024</a:t>
+              <a:t>9/2/2025</a:t>
             </a:fld>
             <a:endParaRPr lang="en-SG"/>
           </a:p>
@@ -2393,7 +2398,7 @@
           <a:p>
             <a:fld id="{06C350D9-E559-450B-A5B6-D4D031A8BEDA}" type="datetimeFigureOut">
               <a:rPr lang="en-SG" smtClean="0"/>
-              <a:t>22/9/2024</a:t>
+              <a:t>9/2/2025</a:t>
             </a:fld>
             <a:endParaRPr lang="en-SG"/>
           </a:p>
@@ -2682,7 +2687,7 @@
           <a:p>
             <a:fld id="{06C350D9-E559-450B-A5B6-D4D031A8BEDA}" type="datetimeFigureOut">
               <a:rPr lang="en-SG" smtClean="0"/>
-              <a:t>22/9/2024</a:t>
+              <a:t>9/2/2025</a:t>
             </a:fld>
             <a:endParaRPr lang="en-SG"/>
           </a:p>
@@ -2925,7 +2930,7 @@
           <a:p>
             <a:fld id="{06C350D9-E559-450B-A5B6-D4D031A8BEDA}" type="datetimeFigureOut">
               <a:rPr lang="en-SG" smtClean="0"/>
-              <a:t>22/9/2024</a:t>
+              <a:t>9/2/2025</a:t>
             </a:fld>
             <a:endParaRPr lang="en-SG"/>
           </a:p>
@@ -3655,8 +3660,8 @@
         </p:nvSpPr>
         <p:spPr>
           <a:xfrm>
-            <a:off x="6883222" y="1434181"/>
-            <a:ext cx="1882054" cy="461665"/>
+            <a:off x="6009620" y="1331537"/>
+            <a:ext cx="3082575" cy="461665"/>
           </a:xfrm>
           <a:prstGeom prst="rect">
             <a:avLst/>
@@ -3671,7 +3676,7 @@
           <a:p>
             <a:r>
               <a:rPr lang="en-US" sz="2400" b="1" dirty="0"/>
-              <a:t>Model server</a:t>
+              <a:t>Model server on Azure</a:t>
             </a:r>
             <a:endParaRPr lang="en-SG" sz="2400" b="1" dirty="0"/>
           </a:p>
@@ -4624,6 +4629,53 @@
           <a:xfrm>
             <a:off x="8918927" y="2323085"/>
             <a:ext cx="1441450" cy="781709"/>
+          </a:xfrm>
+          <a:prstGeom prst="rect">
+            <a:avLst/>
+          </a:prstGeom>
+          <a:noFill/>
+          <a:extLst>
+            <a:ext uri="{909E8E84-426E-40DD-AFC4-6F175D3DCCD1}">
+              <a14:hiddenFill xmlns:a14="http://schemas.microsoft.com/office/drawing/2010/main">
+                <a:solidFill>
+                  <a:srgbClr val="FFFFFF"/>
+                </a:solidFill>
+              </a14:hiddenFill>
+            </a:ext>
+          </a:extLst>
+        </p:spPr>
+      </p:pic>
+      <p:pic>
+        <p:nvPicPr>
+          <p:cNvPr id="3" name="Picture 2" descr="How to Download Microsoft Azure Architecture Icons?">
+            <a:extLst>
+              <a:ext uri="{FF2B5EF4-FFF2-40B4-BE49-F238E27FC236}">
+                <a16:creationId xmlns:a16="http://schemas.microsoft.com/office/drawing/2014/main" id="{40802CD9-79B7-B0B9-2BE5-BFF73B249F7A}"/>
+              </a:ext>
+            </a:extLst>
+          </p:cNvPr>
+          <p:cNvPicPr>
+            <a:picLocks noChangeAspect="1" noChangeArrowheads="1"/>
+          </p:cNvPicPr>
+          <p:nvPr/>
+        </p:nvPicPr>
+        <p:blipFill>
+          <a:blip r:embed="rId5">
+            <a:extLst>
+              <a:ext uri="{28A0092B-C50C-407E-A947-70E740481C1C}">
+                <a14:useLocalDpi xmlns:a14="http://schemas.microsoft.com/office/drawing/2010/main" val="0"/>
+              </a:ext>
+            </a:extLst>
+          </a:blip>
+          <a:srcRect/>
+          <a:stretch>
+            <a:fillRect/>
+          </a:stretch>
+        </p:blipFill>
+        <p:spPr bwMode="auto">
+          <a:xfrm>
+            <a:off x="9048385" y="1254826"/>
+            <a:ext cx="712532" cy="712532"/>
           </a:xfrm>
           <a:prstGeom prst="rect">
             <a:avLst/>

</xml_diff>